<commit_message>
fix formatting errors and add json example for all patterns
</commit_message>
<xml_diff>
--- a/assets/vnf_slide_template.pptx
+++ b/assets/vnf_slide_template.pptx
@@ -1,23 +1,22 @@
 
 <file path=ppt/presentation.xml><?xml version="1.0" encoding="utf-8"?>
-<p:presentation xmlns:a="http://schemas.openxmlformats.org/drawingml/2006/main" xmlns:r="http://schemas.openxmlformats.org/officeDocument/2006/relationships" xmlns:p="http://schemas.openxmlformats.org/presentationml/2006/main" removePersonalInfoOnSave="1" saveSubsetFonts="1">
+<p:presentation xmlns:a="http://schemas.openxmlformats.org/drawingml/2006/main" xmlns:r="http://schemas.openxmlformats.org/officeDocument/2006/relationships" xmlns:p="http://schemas.openxmlformats.org/presentationml/2006/main" removePersonalInfoOnSave="1">
   <p:sldMasterIdLst>
-    <p:sldMasterId id="2147483678" r:id="rId4"/>
+    <p:sldMasterId id="2147483648" r:id="rId1"/>
   </p:sldMasterIdLst>
   <p:notesMasterIdLst>
-    <p:notesMasterId r:id="rId7"/>
+    <p:notesMasterId r:id="rId4"/>
   </p:notesMasterIdLst>
   <p:handoutMasterIdLst>
-    <p:handoutMasterId r:id="rId8"/>
+    <p:handoutMasterId r:id="rId5"/>
   </p:handoutMasterIdLst>
   <p:sldIdLst>
-    <p:sldId id="1977" r:id="rId5"/>
-    <p:sldId id="1628" r:id="rId6"/>
+    <p:sldId id="1977" r:id="rId3"/>
   </p:sldIdLst>
   <p:sldSz cx="9144000" cy="6858000" type="screen4x3"/>
   <p:notesSz cx="7315200" cy="9601200"/>
   <p:custDataLst>
-    <p:tags r:id="rId9"/>
+    <p:tags r:id="rId12"/>
   </p:custDataLst>
   <p:defaultTextStyle>
     <a:defPPr>
@@ -215,7 +214,6 @@
           <a:p>
             <a:fld id="{76DC5076-C0D7-4AF2-9063-F1C0BF846D6E}" type="datetimeFigureOut">
               <a:rPr lang="en-US" smtClean="0"/>
-              <a:t>4/23/26</a:t>
             </a:fld>
             <a:endParaRPr lang="en-US"/>
           </a:p>
@@ -281,18 +279,12 @@
           <a:p>
             <a:fld id="{1060DAB6-898C-4C02-A73E-0E0DF3713DDD}" type="slidenum">
               <a:rPr lang="en-US" smtClean="0"/>
-              <a:t>‹#›</a:t>
             </a:fld>
             <a:endParaRPr lang="en-US"/>
           </a:p>
         </p:txBody>
       </p:sp>
     </p:spTree>
-    <p:extLst>
-      <p:ext uri="{BB962C8B-B14F-4D97-AF65-F5344CB8AC3E}">
-        <p14:creationId xmlns:p14="http://schemas.microsoft.com/office/powerpoint/2010/main" val="4144458330"/>
-      </p:ext>
-    </p:extLst>
   </p:cSld>
   <p:clrMap bg1="lt1" tx1="dk1" bg2="lt2" tx2="dk2" accent1="accent1" accent2="accent2" accent3="accent3" accent4="accent4" accent5="accent5" accent6="accent6" hlink="hlink" folHlink="folHlink"/>
 </p:handoutMaster>
@@ -380,7 +372,6 @@
           <a:p>
             <a:fld id="{03761DBF-6FEA-498D-A646-2CD9AE270865}" type="datetimeFigureOut">
               <a:rPr lang="en-US" smtClean="0"/>
-              <a:t>4/23/26</a:t>
             </a:fld>
             <a:endParaRPr lang="en-US"/>
           </a:p>
@@ -447,6 +438,7 @@
               <a:rPr lang="en-US"/>
               <a:t>Click to edit Master text styles</a:t>
             </a:r>
+            <a:endParaRPr lang="en-US"/>
           </a:p>
           <a:p>
             <a:pPr lvl="1"/>
@@ -454,6 +446,7 @@
               <a:rPr lang="en-US"/>
               <a:t>Second level</a:t>
             </a:r>
+            <a:endParaRPr lang="en-US"/>
           </a:p>
           <a:p>
             <a:pPr lvl="2"/>
@@ -461,6 +454,7 @@
               <a:rPr lang="en-US"/>
               <a:t>Third level</a:t>
             </a:r>
+            <a:endParaRPr lang="en-US"/>
           </a:p>
           <a:p>
             <a:pPr lvl="3"/>
@@ -468,6 +462,7 @@
               <a:rPr lang="en-US"/>
               <a:t>Fourth level</a:t>
             </a:r>
+            <a:endParaRPr lang="en-US"/>
           </a:p>
           <a:p>
             <a:pPr lvl="4"/>
@@ -475,6 +470,7 @@
               <a:rPr lang="en-US"/>
               <a:t>Fifth level</a:t>
             </a:r>
+            <a:endParaRPr lang="en-US"/>
           </a:p>
         </p:txBody>
       </p:sp>
@@ -538,18 +534,12 @@
           <a:p>
             <a:fld id="{32E8A083-D066-4100-8956-8C85C40E5EF6}" type="slidenum">
               <a:rPr lang="en-US" smtClean="0"/>
-              <a:t>‹#›</a:t>
             </a:fld>
             <a:endParaRPr lang="en-US"/>
           </a:p>
         </p:txBody>
       </p:sp>
     </p:spTree>
-    <p:extLst>
-      <p:ext uri="{BB962C8B-B14F-4D97-AF65-F5344CB8AC3E}">
-        <p14:creationId xmlns:p14="http://schemas.microsoft.com/office/powerpoint/2010/main" val="1140354260"/>
-      </p:ext>
-    </p:extLst>
   </p:cSld>
   <p:clrMap bg1="lt1" tx1="dk1" bg2="lt2" tx2="dk2" accent1="accent1" accent2="accent2" accent3="accent3" accent4="accent4" accent5="accent5" accent6="accent6" hlink="hlink" folHlink="folHlink"/>
   <p:notesStyle>
@@ -700,101 +690,12 @@
           <a:lstStyle/>
           <a:p>
             <a:endParaRPr lang="en-US">
-              <a:latin typeface="Cambria"/>
+              <a:latin typeface="Cambria" panose="02040503050406030204"/>
             </a:endParaRPr>
           </a:p>
         </p:txBody>
       </p:sp>
     </p:spTree>
-    <p:extLst>
-      <p:ext uri="{BB962C8B-B14F-4D97-AF65-F5344CB8AC3E}">
-        <p14:creationId xmlns:p14="http://schemas.microsoft.com/office/powerpoint/2010/main" val="1835839066"/>
-      </p:ext>
-    </p:extLst>
-  </p:cSld>
-  <p:clrMapOvr>
-    <a:masterClrMapping/>
-  </p:clrMapOvr>
-</p:notes>
-</file>
-
-<file path=ppt/notesSlides/notesSlide2.xml><?xml version="1.0" encoding="utf-8"?>
-<p:notes xmlns:a="http://schemas.openxmlformats.org/drawingml/2006/main" xmlns:r="http://schemas.openxmlformats.org/officeDocument/2006/relationships" xmlns:p="http://schemas.openxmlformats.org/presentationml/2006/main">
-  <p:cSld>
-    <p:spTree>
-      <p:nvGrpSpPr>
-        <p:cNvPr id="1" name=""/>
-        <p:cNvGrpSpPr/>
-        <p:nvPr/>
-      </p:nvGrpSpPr>
-      <p:grpSpPr>
-        <a:xfrm>
-          <a:off x="0" y="0"/>
-          <a:ext cx="0" cy="0"/>
-          <a:chOff x="0" y="0"/>
-          <a:chExt cx="0" cy="0"/>
-        </a:xfrm>
-      </p:grpSpPr>
-      <p:sp>
-        <p:nvSpPr>
-          <p:cNvPr id="2" name="Slide Image Placeholder 1"/>
-          <p:cNvSpPr>
-            <a:spLocks noGrp="1" noRot="1" noChangeAspect="1"/>
-          </p:cNvSpPr>
-          <p:nvPr>
-            <p:ph type="sldImg"/>
-          </p:nvPr>
-        </p:nvSpPr>
-        <p:spPr/>
-      </p:sp>
-      <p:sp>
-        <p:nvSpPr>
-          <p:cNvPr id="3" name="Notes Placeholder 2"/>
-          <p:cNvSpPr>
-            <a:spLocks noGrp="1"/>
-          </p:cNvSpPr>
-          <p:nvPr>
-            <p:ph type="body" idx="1"/>
-          </p:nvPr>
-        </p:nvSpPr>
-        <p:spPr/>
-        <p:txBody>
-          <a:bodyPr/>
-          <a:lstStyle/>
-          <a:p>
-            <a:endParaRPr lang="en-US"/>
-          </a:p>
-        </p:txBody>
-      </p:sp>
-      <p:sp>
-        <p:nvSpPr>
-          <p:cNvPr id="4" name="Slide Number Placeholder 3"/>
-          <p:cNvSpPr>
-            <a:spLocks noGrp="1"/>
-          </p:cNvSpPr>
-          <p:nvPr>
-            <p:ph type="sldNum" sz="quarter" idx="5"/>
-          </p:nvPr>
-        </p:nvSpPr>
-        <p:spPr/>
-        <p:txBody>
-          <a:bodyPr/>
-          <a:lstStyle/>
-          <a:p>
-            <a:fld id="{32E8A083-D066-4100-8956-8C85C40E5EF6}" type="slidenum">
-              <a:rPr lang="en-US" smtClean="0"/>
-              <a:t>2</a:t>
-            </a:fld>
-            <a:endParaRPr lang="en-US"/>
-          </a:p>
-        </p:txBody>
-      </p:sp>
-    </p:spTree>
-    <p:extLst>
-      <p:ext uri="{BB962C8B-B14F-4D97-AF65-F5344CB8AC3E}">
-        <p14:creationId xmlns:p14="http://schemas.microsoft.com/office/powerpoint/2010/main" val="3592788673"/>
-      </p:ext>
-    </p:extLst>
   </p:cSld>
   <p:clrMapOvr>
     <a:masterClrMapping/>
@@ -821,17 +722,11 @@
       </p:grpSpPr>
       <p:sp>
         <p:nvSpPr>
-          <p:cNvPr id="6" name="Do not remove" hidden="1">
-            <a:extLst>
-              <a:ext uri="{FF2B5EF4-FFF2-40B4-BE49-F238E27FC236}">
-                <a16:creationId xmlns:a16="http://schemas.microsoft.com/office/drawing/2014/main" id="{5F481E45-94B7-4BE5-B523-3D8A8EA66ABB}"/>
-              </a:ext>
-            </a:extLst>
-          </p:cNvPr>
+          <p:cNvPr id="6" name="Do not remove" hidden="1"/>
           <p:cNvSpPr/>
           <p:nvPr userDrawn="1">
             <p:custDataLst>
-              <p:tags r:id="rId1"/>
+              <p:tags r:id="rId2"/>
             </p:custDataLst>
           </p:nvPr>
         </p:nvSpPr>
@@ -860,7 +755,7 @@
               </a14:hiddenFill>
             </a:ext>
             <a:ext uri="{91240B29-F687-4F45-9708-019B960494DF}">
-              <a14:hiddenLine xmlns:a14="http://schemas.microsoft.com/office/drawing/2010/main" w="12700" cap="flat" cmpd="sng" algn="ctr">
+              <a14:hiddenLine xmlns:a14="http://schemas.microsoft.com/office/drawing/2010/main" w="12700">
                 <a:solidFill>
                   <a:schemeClr val="tx1"/>
                 </a:solidFill>
@@ -900,13 +795,7 @@
       </p:sp>
       <p:sp>
         <p:nvSpPr>
-          <p:cNvPr id="10" name="Rectangle 9">
-            <a:extLst>
-              <a:ext uri="{FF2B5EF4-FFF2-40B4-BE49-F238E27FC236}">
-                <a16:creationId xmlns:a16="http://schemas.microsoft.com/office/drawing/2014/main" id="{C82F8F04-D4E8-44C1-B953-9C283C34831B}"/>
-              </a:ext>
-            </a:extLst>
-          </p:cNvPr>
+          <p:cNvPr id="10" name="Rectangle 9"/>
           <p:cNvSpPr/>
           <p:nvPr userDrawn="1"/>
         </p:nvSpPr>
@@ -956,13 +845,7 @@
       </p:sp>
       <p:sp>
         <p:nvSpPr>
-          <p:cNvPr id="11" name="Rectangle 10">
-            <a:extLst>
-              <a:ext uri="{FF2B5EF4-FFF2-40B4-BE49-F238E27FC236}">
-                <a16:creationId xmlns:a16="http://schemas.microsoft.com/office/drawing/2014/main" id="{2073F16A-ECD4-43F3-ADDB-1745C2A9B763}"/>
-              </a:ext>
-            </a:extLst>
-          </p:cNvPr>
+          <p:cNvPr id="11" name="Rectangle 10"/>
           <p:cNvSpPr/>
           <p:nvPr userDrawn="1"/>
         </p:nvSpPr>
@@ -1012,13 +895,7 @@
       </p:sp>
       <p:sp>
         <p:nvSpPr>
-          <p:cNvPr id="7" name="Rectangle 6">
-            <a:extLst>
-              <a:ext uri="{FF2B5EF4-FFF2-40B4-BE49-F238E27FC236}">
-                <a16:creationId xmlns:a16="http://schemas.microsoft.com/office/drawing/2014/main" id="{5BEE902D-1DA2-4FD2-ACE6-69BFCC10A4A3}"/>
-              </a:ext>
-            </a:extLst>
-          </p:cNvPr>
+          <p:cNvPr id="7" name="Rectangle 6"/>
           <p:cNvSpPr/>
           <p:nvPr userDrawn="1"/>
         </p:nvSpPr>
@@ -1068,13 +945,7 @@
       </p:sp>
       <p:sp>
         <p:nvSpPr>
-          <p:cNvPr id="8" name="Rectangle 7">
-            <a:extLst>
-              <a:ext uri="{FF2B5EF4-FFF2-40B4-BE49-F238E27FC236}">
-                <a16:creationId xmlns:a16="http://schemas.microsoft.com/office/drawing/2014/main" id="{6EC01111-EE0A-4069-837E-2BD15A9A91B1}"/>
-              </a:ext>
-            </a:extLst>
-          </p:cNvPr>
+          <p:cNvPr id="8" name="Rectangle 7"/>
           <p:cNvSpPr/>
           <p:nvPr userDrawn="1"/>
         </p:nvSpPr>
@@ -1123,11 +994,6 @@
         </p:txBody>
       </p:sp>
     </p:spTree>
-    <p:extLst>
-      <p:ext uri="{BB962C8B-B14F-4D97-AF65-F5344CB8AC3E}">
-        <p14:creationId xmlns:p14="http://schemas.microsoft.com/office/powerpoint/2010/main" val="4228104966"/>
-      </p:ext>
-    </p:extLst>
   </p:cSld>
   <p:clrMapOvr>
     <a:masterClrMapping/>
@@ -1154,17 +1020,11 @@
       </p:grpSpPr>
       <p:sp>
         <p:nvSpPr>
-          <p:cNvPr id="2" name="Do not remove" hidden="1">
-            <a:extLst>
-              <a:ext uri="{FF2B5EF4-FFF2-40B4-BE49-F238E27FC236}">
-                <a16:creationId xmlns:a16="http://schemas.microsoft.com/office/drawing/2014/main" id="{8EBBC3EB-0869-418C-B246-16E5887C92D4}"/>
-              </a:ext>
-            </a:extLst>
-          </p:cNvPr>
+          <p:cNvPr id="2" name="Do not remove" hidden="1"/>
           <p:cNvSpPr/>
           <p:nvPr userDrawn="1">
             <p:custDataLst>
-              <p:tags r:id="rId1"/>
+              <p:tags r:id="rId2"/>
             </p:custDataLst>
           </p:nvPr>
         </p:nvSpPr>
@@ -1193,7 +1053,7 @@
               </a14:hiddenFill>
             </a:ext>
             <a:ext uri="{91240B29-F687-4F45-9708-019B960494DF}">
-              <a14:hiddenLine xmlns:a14="http://schemas.microsoft.com/office/drawing/2010/main" w="12700" cap="flat" cmpd="sng" algn="ctr">
+              <a14:hiddenLine xmlns:a14="http://schemas.microsoft.com/office/drawing/2010/main" w="12700">
                 <a:solidFill>
                   <a:schemeClr val="tx1"/>
                 </a:solidFill>
@@ -1233,13 +1093,7 @@
       </p:sp>
       <p:cxnSp>
         <p:nvCxnSpPr>
-          <p:cNvPr id="9" name="Straight Connector 8">
-            <a:extLst>
-              <a:ext uri="{FF2B5EF4-FFF2-40B4-BE49-F238E27FC236}">
-                <a16:creationId xmlns:a16="http://schemas.microsoft.com/office/drawing/2014/main" id="{B830F331-71AE-4039-B927-3FEC800FBDC9}"/>
-              </a:ext>
-            </a:extLst>
-          </p:cNvPr>
+          <p:cNvPr id="9" name="Straight Connector 8"/>
           <p:cNvCxnSpPr/>
           <p:nvPr userDrawn="1"/>
         </p:nvCxnSpPr>
@@ -1289,13 +1143,7 @@
       </p:cxnSp>
       <p:cxnSp>
         <p:nvCxnSpPr>
-          <p:cNvPr id="10" name="Straight Connector 9">
-            <a:extLst>
-              <a:ext uri="{FF2B5EF4-FFF2-40B4-BE49-F238E27FC236}">
-                <a16:creationId xmlns:a16="http://schemas.microsoft.com/office/drawing/2014/main" id="{4B0221FD-E3B8-4CDA-AF40-CF1F109903C4}"/>
-              </a:ext>
-            </a:extLst>
-          </p:cNvPr>
+          <p:cNvPr id="10" name="Straight Connector 9"/>
           <p:cNvCxnSpPr/>
           <p:nvPr userDrawn="1"/>
         </p:nvCxnSpPr>
@@ -1345,13 +1193,7 @@
       </p:cxnSp>
       <p:sp>
         <p:nvSpPr>
-          <p:cNvPr id="11" name="Slide Number Placeholder 5">
-            <a:extLst>
-              <a:ext uri="{FF2B5EF4-FFF2-40B4-BE49-F238E27FC236}">
-                <a16:creationId xmlns:a16="http://schemas.microsoft.com/office/drawing/2014/main" id="{0CB37A10-E80C-4FAB-8B40-2E3F004F4A50}"/>
-              </a:ext>
-            </a:extLst>
-          </p:cNvPr>
+          <p:cNvPr id="11" name="Slide Number Placeholder 5"/>
           <p:cNvSpPr>
             <a:spLocks noGrp="1"/>
           </p:cNvSpPr>
@@ -1390,8 +1232,6 @@
                   </a:prstClr>
                 </a:solidFill>
               </a:rPr>
-              <a:pPr/>
-              <a:t>‹#›</a:t>
             </a:fld>
             <a:endParaRPr lang="en-US">
               <a:solidFill>
@@ -1405,13 +1245,7 @@
       </p:sp>
       <p:sp>
         <p:nvSpPr>
-          <p:cNvPr id="12" name="Title Placeholder 13">
-            <a:extLst>
-              <a:ext uri="{FF2B5EF4-FFF2-40B4-BE49-F238E27FC236}">
-                <a16:creationId xmlns:a16="http://schemas.microsoft.com/office/drawing/2014/main" id="{81C910CD-7CA6-4489-A230-4C3C3EC470F5}"/>
-              </a:ext>
-            </a:extLst>
-          </p:cNvPr>
+          <p:cNvPr id="12" name="Title Placeholder 13"/>
           <p:cNvSpPr>
             <a:spLocks noGrp="1"/>
           </p:cNvSpPr>
@@ -1447,33 +1281,24 @@
               <a:rPr lang="en-US" dirty="0"/>
               <a:t>Click to edit Master title style</a:t>
             </a:r>
+            <a:endParaRPr lang="en-US" dirty="0"/>
           </a:p>
         </p:txBody>
       </p:sp>
       <p:pic>
         <p:nvPicPr>
-          <p:cNvPr id="3" name="Picture 2" descr="A close up of a logo&#10;&#10;Description automatically generated">
-            <a:extLst>
-              <a:ext uri="{FF2B5EF4-FFF2-40B4-BE49-F238E27FC236}">
-                <a16:creationId xmlns:a16="http://schemas.microsoft.com/office/drawing/2014/main" id="{E11C3A2E-8D22-CF02-5433-9F2647FA9498}"/>
-              </a:ext>
-            </a:extLst>
-          </p:cNvPr>
+          <p:cNvPr id="3" name="Picture 2" descr="A close up of a logo&#10;&#10;Description automatically generated"/>
           <p:cNvPicPr>
             <a:picLocks noChangeAspect="1"/>
           </p:cNvPicPr>
           <p:nvPr userDrawn="1"/>
         </p:nvPicPr>
         <p:blipFill rotWithShape="1">
-          <a:blip r:embed="rId3" cstate="print">
-            <a:extLst>
-              <a:ext uri="{28A0092B-C50C-407E-A947-70E740481C1C}">
-                <a14:useLocalDpi xmlns:a14="http://schemas.microsoft.com/office/drawing/2010/main"/>
-              </a:ext>
-            </a:extLst>
-          </a:blip>
+          <a:blip r:embed="rId3" cstate="print"/>
           <a:srcRect/>
-          <a:stretch/>
+          <a:stretch>
+            <a:fillRect/>
+          </a:stretch>
         </p:blipFill>
         <p:spPr>
           <a:xfrm>
@@ -1487,16 +1312,8 @@
       </p:pic>
       <p:sp>
         <p:nvSpPr>
-          <p:cNvPr id="4" name="Slide Number Placeholder 5">
-            <a:extLst>
-              <a:ext uri="{FF2B5EF4-FFF2-40B4-BE49-F238E27FC236}">
-                <a16:creationId xmlns:a16="http://schemas.microsoft.com/office/drawing/2014/main" id="{28B6522C-158A-420F-69D8-53C9DDA4FFC9}"/>
-              </a:ext>
-            </a:extLst>
-          </p:cNvPr>
-          <p:cNvSpPr txBox="1">
-            <a:spLocks/>
-          </p:cNvSpPr>
+          <p:cNvPr id="4" name="Slide Number Placeholder 5"/>
+          <p:cNvSpPr txBox="1"/>
           <p:nvPr userDrawn="1"/>
         </p:nvSpPr>
         <p:spPr>
@@ -1616,8 +1433,6 @@
                   </a:prstClr>
                 </a:solidFill>
               </a:rPr>
-              <a:pPr/>
-              <a:t>‹#›</a:t>
             </a:fld>
             <a:endParaRPr lang="en-US">
               <a:solidFill>
@@ -1631,16 +1446,8 @@
       </p:sp>
       <p:sp>
         <p:nvSpPr>
-          <p:cNvPr id="5" name="Footer Placeholder 4">
-            <a:extLst>
-              <a:ext uri="{FF2B5EF4-FFF2-40B4-BE49-F238E27FC236}">
-                <a16:creationId xmlns:a16="http://schemas.microsoft.com/office/drawing/2014/main" id="{038079DC-B545-CF14-9213-43135A3E9434}"/>
-              </a:ext>
-            </a:extLst>
-          </p:cNvPr>
-          <p:cNvSpPr txBox="1">
-            <a:spLocks/>
-          </p:cNvSpPr>
+          <p:cNvPr id="5" name="Footer Placeholder 4"/>
+          <p:cNvSpPr txBox="1"/>
           <p:nvPr userDrawn="1"/>
         </p:nvSpPr>
         <p:spPr>
@@ -1762,15 +1569,17 @@
               </a:rPr>
               <a:t>Confidential</a:t>
             </a:r>
+            <a:endParaRPr lang="en-US" sz="1200" dirty="0">
+              <a:solidFill>
+                <a:prstClr val="black">
+                  <a:tint val="75000"/>
+                </a:prstClr>
+              </a:solidFill>
+            </a:endParaRPr>
           </a:p>
         </p:txBody>
       </p:sp>
     </p:spTree>
-    <p:extLst>
-      <p:ext uri="{BB962C8B-B14F-4D97-AF65-F5344CB8AC3E}">
-        <p14:creationId xmlns:p14="http://schemas.microsoft.com/office/powerpoint/2010/main" val="3217778953"/>
-      </p:ext>
-    </p:extLst>
   </p:cSld>
   <p:clrMapOvr>
     <a:masterClrMapping/>
@@ -1804,16 +1613,11 @@
         </a:xfrm>
       </p:grpSpPr>
     </p:spTree>
-    <p:extLst>
-      <p:ext uri="{BB962C8B-B14F-4D97-AF65-F5344CB8AC3E}">
-        <p14:creationId xmlns:p14="http://schemas.microsoft.com/office/powerpoint/2010/main" val="625377384"/>
-      </p:ext>
-    </p:extLst>
   </p:cSld>
   <p:clrMap bg1="lt1" tx1="dk1" bg2="lt2" tx2="dk2" accent1="accent1" accent2="accent2" accent3="accent3" accent4="accent4" accent5="accent5" accent6="accent6" hlink="hlink" folHlink="folHlink"/>
   <p:sldLayoutIdLst>
-    <p:sldLayoutId id="2147483752" r:id="rId1"/>
-    <p:sldLayoutId id="2147483751" r:id="rId2"/>
+    <p:sldLayoutId id="2147483649" r:id="rId1"/>
+    <p:sldLayoutId id="2147483650" r:id="rId2"/>
   </p:sldLayoutIdLst>
   <p:hf hdr="0" dt="0"/>
   <p:txStyles>
@@ -1838,7 +1642,7 @@
         <a:spcBef>
           <a:spcPct val="20000"/>
         </a:spcBef>
-        <a:buFont typeface="Arial" pitchFamily="34" charset="0"/>
+        <a:buFont typeface="Arial" panose="020B0604020202020204" pitchFamily="34" charset="0"/>
         <a:buChar char="•"/>
         <a:defRPr sz="1800" kern="1200">
           <a:solidFill>
@@ -1853,7 +1657,7 @@
         <a:spcBef>
           <a:spcPct val="20000"/>
         </a:spcBef>
-        <a:buFont typeface="Arial" pitchFamily="34" charset="0"/>
+        <a:buFont typeface="Arial" panose="020B0604020202020204" pitchFamily="34" charset="0"/>
         <a:buChar char="–"/>
         <a:defRPr sz="1600" kern="1200">
           <a:solidFill>
@@ -1868,7 +1672,7 @@
         <a:spcBef>
           <a:spcPct val="20000"/>
         </a:spcBef>
-        <a:buFont typeface="Arial" pitchFamily="34" charset="0"/>
+        <a:buFont typeface="Arial" panose="020B0604020202020204" pitchFamily="34" charset="0"/>
         <a:buChar char="•"/>
         <a:defRPr sz="1400" kern="1200">
           <a:solidFill>
@@ -1883,7 +1687,7 @@
         <a:spcBef>
           <a:spcPct val="20000"/>
         </a:spcBef>
-        <a:buFont typeface="Arial" pitchFamily="34" charset="0"/>
+        <a:buFont typeface="Arial" panose="020B0604020202020204" pitchFamily="34" charset="0"/>
         <a:buChar char="–"/>
         <a:defRPr sz="1200" kern="1200">
           <a:solidFill>
@@ -1898,7 +1702,7 @@
         <a:spcBef>
           <a:spcPct val="20000"/>
         </a:spcBef>
-        <a:buFont typeface="Arial" pitchFamily="34" charset="0"/>
+        <a:buFont typeface="Arial" panose="020B0604020202020204" pitchFamily="34" charset="0"/>
         <a:buChar char="»"/>
         <a:defRPr sz="1100" kern="1200">
           <a:solidFill>
@@ -1913,7 +1717,7 @@
         <a:spcBef>
           <a:spcPct val="20000"/>
         </a:spcBef>
-        <a:buFont typeface="Arial" pitchFamily="34" charset="0"/>
+        <a:buFont typeface="Arial" panose="020B0604020202020204" pitchFamily="34" charset="0"/>
         <a:buChar char="•"/>
         <a:defRPr sz="2000" kern="1200">
           <a:solidFill>
@@ -1928,7 +1732,7 @@
         <a:spcBef>
           <a:spcPct val="20000"/>
         </a:spcBef>
-        <a:buFont typeface="Arial" pitchFamily="34" charset="0"/>
+        <a:buFont typeface="Arial" panose="020B0604020202020204" pitchFamily="34" charset="0"/>
         <a:buChar char="•"/>
         <a:defRPr sz="2000" kern="1200">
           <a:solidFill>
@@ -1943,7 +1747,7 @@
         <a:spcBef>
           <a:spcPct val="20000"/>
         </a:spcBef>
-        <a:buFont typeface="Arial" pitchFamily="34" charset="0"/>
+        <a:buFont typeface="Arial" panose="020B0604020202020204" pitchFamily="34" charset="0"/>
         <a:buChar char="•"/>
         <a:defRPr sz="2000" kern="1200">
           <a:solidFill>
@@ -1958,7 +1762,7 @@
         <a:spcBef>
           <a:spcPct val="20000"/>
         </a:spcBef>
-        <a:buFont typeface="Arial" pitchFamily="34" charset="0"/>
+        <a:buFont typeface="Arial" panose="020B0604020202020204" pitchFamily="34" charset="0"/>
         <a:buChar char="•"/>
         <a:defRPr sz="2000" kern="1200">
           <a:solidFill>
@@ -2088,13 +1892,7 @@
       </p:grpSpPr>
       <p:sp>
         <p:nvSpPr>
-          <p:cNvPr id="2" name="Rectangle 1">
-            <a:extLst>
-              <a:ext uri="{FF2B5EF4-FFF2-40B4-BE49-F238E27FC236}">
-                <a16:creationId xmlns:a16="http://schemas.microsoft.com/office/drawing/2014/main" id="{36F97A14-C8B2-8A3C-8541-B92D4D8BD26E}"/>
-              </a:ext>
-            </a:extLst>
-          </p:cNvPr>
+          <p:cNvPr id="2" name="Rectangle 1"/>
           <p:cNvSpPr/>
           <p:nvPr/>
         </p:nvSpPr>
@@ -2107,7 +1905,7 @@
             <a:avLst/>
           </a:prstGeom>
           <a:blipFill dpi="0" rotWithShape="1">
-            <a:blip r:embed="rId3">
+            <a:blip r:embed="rId1">
               <a:alphaModFix amt="15000"/>
             </a:blip>
             <a:srcRect/>
@@ -2153,7 +1951,6 @@
               <a:buSzTx/>
               <a:buFontTx/>
               <a:buNone/>
-              <a:tabLst/>
               <a:defRPr/>
             </a:pPr>
             <a:endParaRPr kumimoji="0" lang="en-US" sz="1100" b="0" i="0" u="none" strike="noStrike" kern="1200" cap="none" spc="0" normalizeH="0" baseline="0" noProof="0">
@@ -2166,7 +1963,7 @@
               <a:effectLst/>
               <a:uLnTx/>
               <a:uFillTx/>
-              <a:latin typeface="Calibri"/>
+              <a:latin typeface="Calibri" panose="020F0502020204030204"/>
               <a:ea typeface="+mn-ea"/>
               <a:cs typeface="+mn-cs"/>
             </a:endParaRPr>
@@ -2175,13 +1972,7 @@
       </p:sp>
       <p:sp>
         <p:nvSpPr>
-          <p:cNvPr id="19" name="Rectangle 18">
-            <a:extLst>
-              <a:ext uri="{FF2B5EF4-FFF2-40B4-BE49-F238E27FC236}">
-                <a16:creationId xmlns:a16="http://schemas.microsoft.com/office/drawing/2014/main" id="{783374BE-54C4-418F-9BC5-B43C87F741C6}"/>
-              </a:ext>
-            </a:extLst>
-          </p:cNvPr>
+          <p:cNvPr id="19" name="Rectangle 18"/>
           <p:cNvSpPr/>
           <p:nvPr/>
         </p:nvSpPr>
@@ -2236,7 +2027,6 @@
               <a:buSzTx/>
               <a:buFontTx/>
               <a:buNone/>
-              <a:tabLst/>
               <a:defRPr/>
             </a:pPr>
             <a:endParaRPr kumimoji="0" lang="vi-VN" sz="3200" b="1" i="0" u="none" strike="noStrike" kern="1200" cap="all" spc="0" normalizeH="0" baseline="0" noProof="0">
@@ -2264,13 +2054,7 @@
       </p:sp>
       <p:sp>
         <p:nvSpPr>
-          <p:cNvPr id="36" name="Rectangle: Rounded Corners 35">
-            <a:extLst>
-              <a:ext uri="{FF2B5EF4-FFF2-40B4-BE49-F238E27FC236}">
-                <a16:creationId xmlns:a16="http://schemas.microsoft.com/office/drawing/2014/main" id="{2479360C-277A-48EA-9735-CFEB2AD0BF0A}"/>
-              </a:ext>
-            </a:extLst>
-          </p:cNvPr>
+          <p:cNvPr id="36" name="Rectangle: Rounded Corners 35"/>
           <p:cNvSpPr/>
           <p:nvPr/>
         </p:nvSpPr>
@@ -2360,19 +2144,157 @@
       </p:sp>
       <p:sp>
         <p:nvSpPr>
-          <p:cNvPr id="11" name="TextBox 10">
-            <a:extLst>
-              <a:ext uri="{FF2B5EF4-FFF2-40B4-BE49-F238E27FC236}">
-                <a16:creationId xmlns:a16="http://schemas.microsoft.com/office/drawing/2014/main" id="{0A1A1A6D-0AD0-164F-A0DF-CE5154B4A2DC}"/>
-              </a:ext>
-            </a:extLst>
-          </p:cNvPr>
+          <p:cNvPr id="11" name="TextBox 10"/>
           <p:cNvSpPr txBox="1"/>
           <p:nvPr/>
         </p:nvSpPr>
         <p:spPr>
           <a:xfrm>
             <a:off x="959250" y="557013"/>
+            <a:ext cx="1568536" cy="1189113"/>
+          </a:xfrm>
+          <a:prstGeom prst="roundRect">
+            <a:avLst/>
+          </a:prstGeom>
+          <a:blipFill dpi="0" rotWithShape="1">
+            <a:blip r:embed="rId2" cstate="print">
+              <a:extLst>
+                <a:ext uri="{28A0092B-C50C-407E-A947-70E740481C1C}">
+                  <a14:useLocalDpi xmlns:a14="http://schemas.microsoft.com/office/drawing/2010/main" val="0"/>
+                </a:ext>
+              </a:extLst>
+            </a:blip>
+            <a:srcRect/>
+            <a:stretch>
+              <a:fillRect/>
+            </a:stretch>
+          </a:blipFill>
+          <a:ln w="12700">
+            <a:solidFill>
+              <a:schemeClr val="bg1"/>
+            </a:solidFill>
+          </a:ln>
+        </p:spPr>
+        <p:txBody>
+          <a:bodyPr wrap="square" rtlCol="0">
+            <a:noAutofit/>
+          </a:bodyPr>
+          <a:lstStyle/>
+          <a:p>
+            <a:pPr marL="0" marR="0" lvl="0" indent="0" algn="l" defTabSz="914400" rtl="0" eaLnBrk="1" fontAlgn="auto" latinLnBrk="0" hangingPunct="1">
+              <a:lnSpc>
+                <a:spcPct val="100000"/>
+              </a:lnSpc>
+              <a:spcBef>
+                <a:spcPts val="0"/>
+              </a:spcBef>
+              <a:spcAft>
+                <a:spcPts val="0"/>
+              </a:spcAft>
+              <a:buClrTx/>
+              <a:buSzTx/>
+              <a:buFontTx/>
+              <a:buNone/>
+              <a:defRPr/>
+            </a:pPr>
+            <a:endParaRPr kumimoji="0" lang="en-US" sz="1800" b="0" i="0" u="none" strike="noStrike" kern="1200" cap="none" spc="0" normalizeH="0" baseline="0" noProof="0">
+              <a:ln>
+                <a:noFill/>
+              </a:ln>
+              <a:solidFill>
+                <a:prstClr val="black"/>
+              </a:solidFill>
+              <a:effectLst/>
+              <a:uLnTx/>
+              <a:uFillTx/>
+              <a:latin typeface="Calibri" panose="020F0502020204030204"/>
+              <a:ea typeface="+mn-ea"/>
+              <a:cs typeface="+mn-cs"/>
+            </a:endParaRPr>
+          </a:p>
+        </p:txBody>
+      </p:sp>
+      <p:sp>
+        <p:nvSpPr>
+          <p:cNvPr id="24" name="TextBox 23"/>
+          <p:cNvSpPr txBox="1"/>
+          <p:nvPr/>
+        </p:nvSpPr>
+        <p:spPr>
+          <a:xfrm>
+            <a:off x="4617092" y="522126"/>
+            <a:ext cx="1568536" cy="1224000"/>
+          </a:xfrm>
+          <a:prstGeom prst="roundRect">
+            <a:avLst/>
+          </a:prstGeom>
+          <a:blipFill dpi="0" rotWithShape="1">
+            <a:blip r:embed="rId3" cstate="print">
+              <a:extLst>
+                <a:ext uri="{28A0092B-C50C-407E-A947-70E740481C1C}">
+                  <a14:useLocalDpi xmlns:a14="http://schemas.microsoft.com/office/drawing/2010/main" val="0"/>
+                </a:ext>
+              </a:extLst>
+            </a:blip>
+            <a:srcRect/>
+            <a:stretch>
+              <a:fillRect/>
+            </a:stretch>
+          </a:blipFill>
+          <a:ln w="12700">
+            <a:solidFill>
+              <a:schemeClr val="bg1"/>
+            </a:solidFill>
+          </a:ln>
+        </p:spPr>
+        <p:txBody>
+          <a:bodyPr wrap="square" rtlCol="0">
+            <a:noAutofit/>
+          </a:bodyPr>
+          <a:lstStyle/>
+          <a:p>
+            <a:pPr marL="0" marR="0" lvl="0" indent="0" algn="l" defTabSz="914400" rtl="0" eaLnBrk="1" fontAlgn="auto" latinLnBrk="0" hangingPunct="1">
+              <a:lnSpc>
+                <a:spcPct val="100000"/>
+              </a:lnSpc>
+              <a:spcBef>
+                <a:spcPts val="0"/>
+              </a:spcBef>
+              <a:spcAft>
+                <a:spcPts val="0"/>
+              </a:spcAft>
+              <a:buClrTx/>
+              <a:buSzTx/>
+              <a:buFontTx/>
+              <a:buNone/>
+              <a:defRPr/>
+            </a:pPr>
+            <a:endParaRPr kumimoji="0" lang="en-US" sz="1800" b="0" i="0" u="none" strike="noStrike" kern="1200" cap="none" spc="0" normalizeH="0" baseline="0" noProof="0">
+              <a:ln>
+                <a:noFill/>
+              </a:ln>
+              <a:solidFill>
+                <a:prstClr val="black"/>
+              </a:solidFill>
+              <a:effectLst/>
+              <a:uLnTx/>
+              <a:uFillTx/>
+              <a:latin typeface="Calibri" panose="020F0502020204030204"/>
+              <a:ea typeface="+mn-ea"/>
+              <a:cs typeface="+mn-cs"/>
+            </a:endParaRPr>
+          </a:p>
+        </p:txBody>
+      </p:sp>
+      <p:sp>
+        <p:nvSpPr>
+          <p:cNvPr id="25" name="TextBox 24"/>
+          <p:cNvSpPr txBox="1"/>
+          <p:nvPr/>
+        </p:nvSpPr>
+        <p:spPr>
+          <a:xfrm>
+            <a:off x="2788171" y="522126"/>
             <a:ext cx="1568536" cy="1189113"/>
           </a:xfrm>
           <a:prstGeom prst="roundRect">
@@ -2417,7 +2339,6 @@
               <a:buSzTx/>
               <a:buFontTx/>
               <a:buNone/>
-              <a:tabLst/>
               <a:defRPr/>
             </a:pPr>
             <a:endParaRPr kumimoji="0" lang="en-US" sz="1800" b="0" i="0" u="none" strike="noStrike" kern="1200" cap="none" spc="0" normalizeH="0" baseline="0" noProof="0">
@@ -2439,19 +2360,13 @@
       </p:sp>
       <p:sp>
         <p:nvSpPr>
-          <p:cNvPr id="24" name="TextBox 23">
-            <a:extLst>
-              <a:ext uri="{FF2B5EF4-FFF2-40B4-BE49-F238E27FC236}">
-                <a16:creationId xmlns:a16="http://schemas.microsoft.com/office/drawing/2014/main" id="{8996C0B7-31CD-2440-B8C6-8C28FC36198C}"/>
-              </a:ext>
-            </a:extLst>
-          </p:cNvPr>
+          <p:cNvPr id="28" name="TextBox 27"/>
           <p:cNvSpPr txBox="1"/>
           <p:nvPr/>
         </p:nvSpPr>
         <p:spPr>
           <a:xfrm>
-            <a:off x="4617092" y="522126"/>
+            <a:off x="6481329" y="522126"/>
             <a:ext cx="1568536" cy="1224000"/>
           </a:xfrm>
           <a:prstGeom prst="roundRect">
@@ -2496,165 +2411,6 @@
               <a:buSzTx/>
               <a:buFontTx/>
               <a:buNone/>
-              <a:tabLst/>
-              <a:defRPr/>
-            </a:pPr>
-            <a:endParaRPr kumimoji="0" lang="en-US" sz="1800" b="0" i="0" u="none" strike="noStrike" kern="1200" cap="none" spc="0" normalizeH="0" baseline="0" noProof="0">
-              <a:ln>
-                <a:noFill/>
-              </a:ln>
-              <a:solidFill>
-                <a:prstClr val="black"/>
-              </a:solidFill>
-              <a:effectLst/>
-              <a:uLnTx/>
-              <a:uFillTx/>
-              <a:latin typeface="Calibri" panose="020F0502020204030204"/>
-              <a:ea typeface="+mn-ea"/>
-              <a:cs typeface="+mn-cs"/>
-            </a:endParaRPr>
-          </a:p>
-        </p:txBody>
-      </p:sp>
-      <p:sp>
-        <p:nvSpPr>
-          <p:cNvPr id="25" name="TextBox 24">
-            <a:extLst>
-              <a:ext uri="{FF2B5EF4-FFF2-40B4-BE49-F238E27FC236}">
-                <a16:creationId xmlns:a16="http://schemas.microsoft.com/office/drawing/2014/main" id="{9F9085AE-D650-C549-88E0-4D4C339403E7}"/>
-              </a:ext>
-            </a:extLst>
-          </p:cNvPr>
-          <p:cNvSpPr txBox="1"/>
-          <p:nvPr/>
-        </p:nvSpPr>
-        <p:spPr>
-          <a:xfrm>
-            <a:off x="2788171" y="522126"/>
-            <a:ext cx="1568536" cy="1189113"/>
-          </a:xfrm>
-          <a:prstGeom prst="roundRect">
-            <a:avLst/>
-          </a:prstGeom>
-          <a:blipFill dpi="0" rotWithShape="1">
-            <a:blip r:embed="rId6" cstate="print">
-              <a:extLst>
-                <a:ext uri="{28A0092B-C50C-407E-A947-70E740481C1C}">
-                  <a14:useLocalDpi xmlns:a14="http://schemas.microsoft.com/office/drawing/2010/main" val="0"/>
-                </a:ext>
-              </a:extLst>
-            </a:blip>
-            <a:srcRect/>
-            <a:stretch>
-              <a:fillRect/>
-            </a:stretch>
-          </a:blipFill>
-          <a:ln w="12700">
-            <a:solidFill>
-              <a:schemeClr val="bg1"/>
-            </a:solidFill>
-          </a:ln>
-        </p:spPr>
-        <p:txBody>
-          <a:bodyPr wrap="square" rtlCol="0">
-            <a:noAutofit/>
-          </a:bodyPr>
-          <a:lstStyle/>
-          <a:p>
-            <a:pPr marL="0" marR="0" lvl="0" indent="0" algn="l" defTabSz="914400" rtl="0" eaLnBrk="1" fontAlgn="auto" latinLnBrk="0" hangingPunct="1">
-              <a:lnSpc>
-                <a:spcPct val="100000"/>
-              </a:lnSpc>
-              <a:spcBef>
-                <a:spcPts val="0"/>
-              </a:spcBef>
-              <a:spcAft>
-                <a:spcPts val="0"/>
-              </a:spcAft>
-              <a:buClrTx/>
-              <a:buSzTx/>
-              <a:buFontTx/>
-              <a:buNone/>
-              <a:tabLst/>
-              <a:defRPr/>
-            </a:pPr>
-            <a:endParaRPr kumimoji="0" lang="en-US" sz="1800" b="0" i="0" u="none" strike="noStrike" kern="1200" cap="none" spc="0" normalizeH="0" baseline="0" noProof="0">
-              <a:ln>
-                <a:noFill/>
-              </a:ln>
-              <a:solidFill>
-                <a:prstClr val="black"/>
-              </a:solidFill>
-              <a:effectLst/>
-              <a:uLnTx/>
-              <a:uFillTx/>
-              <a:latin typeface="Calibri" panose="020F0502020204030204"/>
-              <a:ea typeface="+mn-ea"/>
-              <a:cs typeface="+mn-cs"/>
-            </a:endParaRPr>
-          </a:p>
-        </p:txBody>
-      </p:sp>
-      <p:sp>
-        <p:nvSpPr>
-          <p:cNvPr id="28" name="TextBox 27">
-            <a:extLst>
-              <a:ext uri="{FF2B5EF4-FFF2-40B4-BE49-F238E27FC236}">
-                <a16:creationId xmlns:a16="http://schemas.microsoft.com/office/drawing/2014/main" id="{6A74CC2E-DC8A-1B49-911C-F449F9510C2C}"/>
-              </a:ext>
-            </a:extLst>
-          </p:cNvPr>
-          <p:cNvSpPr txBox="1"/>
-          <p:nvPr/>
-        </p:nvSpPr>
-        <p:spPr>
-          <a:xfrm>
-            <a:off x="6481329" y="522126"/>
-            <a:ext cx="1568536" cy="1224000"/>
-          </a:xfrm>
-          <a:prstGeom prst="roundRect">
-            <a:avLst/>
-          </a:prstGeom>
-          <a:blipFill dpi="0" rotWithShape="1">
-            <a:blip r:embed="rId7" cstate="print">
-              <a:extLst>
-                <a:ext uri="{28A0092B-C50C-407E-A947-70E740481C1C}">
-                  <a14:useLocalDpi xmlns:a14="http://schemas.microsoft.com/office/drawing/2010/main" val="0"/>
-                </a:ext>
-              </a:extLst>
-            </a:blip>
-            <a:srcRect/>
-            <a:stretch>
-              <a:fillRect/>
-            </a:stretch>
-          </a:blipFill>
-          <a:ln w="12700">
-            <a:solidFill>
-              <a:schemeClr val="bg1"/>
-            </a:solidFill>
-          </a:ln>
-        </p:spPr>
-        <p:txBody>
-          <a:bodyPr wrap="square" rtlCol="0">
-            <a:noAutofit/>
-          </a:bodyPr>
-          <a:lstStyle/>
-          <a:p>
-            <a:pPr marL="0" marR="0" lvl="0" indent="0" algn="l" defTabSz="914400" rtl="0" eaLnBrk="1" fontAlgn="auto" latinLnBrk="0" hangingPunct="1">
-              <a:lnSpc>
-                <a:spcPct val="100000"/>
-              </a:lnSpc>
-              <a:spcBef>
-                <a:spcPts val="0"/>
-              </a:spcBef>
-              <a:spcAft>
-                <a:spcPts val="0"/>
-              </a:spcAft>
-              <a:buClrTx/>
-              <a:buSzTx/>
-              <a:buFontTx/>
-              <a:buNone/>
-              <a:tabLst/>
               <a:defRPr/>
             </a:pPr>
             <a:endParaRPr kumimoji="0" lang="en-US" sz="1800" b="0" i="0" u="none" strike="noStrike" kern="1200" cap="none" spc="0" normalizeH="0" baseline="0" noProof="0">
@@ -2676,20 +2432,14 @@
       </p:sp>
       <p:pic>
         <p:nvPicPr>
-          <p:cNvPr id="16" name="Picture 15">
-            <a:extLst>
-              <a:ext uri="{FF2B5EF4-FFF2-40B4-BE49-F238E27FC236}">
-                <a16:creationId xmlns:a16="http://schemas.microsoft.com/office/drawing/2014/main" id="{C1411D70-C17A-6143-BF3E-09CAC6D67A33}"/>
-              </a:ext>
-            </a:extLst>
-          </p:cNvPr>
+          <p:cNvPr id="16" name="Picture 15"/>
           <p:cNvPicPr>
             <a:picLocks noChangeAspect="1"/>
           </p:cNvPicPr>
           <p:nvPr/>
         </p:nvPicPr>
         <p:blipFill rotWithShape="1">
-          <a:blip r:embed="rId8" cstate="print">
+          <a:blip r:embed="rId6" cstate="print">
             <a:extLst>
               <a:ext uri="{28A0092B-C50C-407E-A947-70E740481C1C}">
                 <a14:useLocalDpi xmlns:a14="http://schemas.microsoft.com/office/drawing/2010/main" val="0"/>
@@ -2697,7 +2447,9 @@
             </a:extLst>
           </a:blip>
           <a:srcRect/>
-          <a:stretch/>
+          <a:stretch>
+            <a:fillRect/>
+          </a:stretch>
         </p:blipFill>
         <p:spPr>
           <a:xfrm>
@@ -2711,13 +2463,7 @@
       </p:pic>
       <p:sp>
         <p:nvSpPr>
-          <p:cNvPr id="14" name="TextBox 13">
-            <a:extLst>
-              <a:ext uri="{FF2B5EF4-FFF2-40B4-BE49-F238E27FC236}">
-                <a16:creationId xmlns:a16="http://schemas.microsoft.com/office/drawing/2014/main" id="{4907C326-EE56-4377-8FD7-0E509EA9BC46}"/>
-              </a:ext>
-            </a:extLst>
-          </p:cNvPr>
+          <p:cNvPr id="14" name="TextBox 13"/>
           <p:cNvSpPr txBox="1"/>
           <p:nvPr/>
         </p:nvSpPr>
@@ -2737,7 +2483,7 @@
           </a:bodyPr>
           <a:lstStyle/>
           <a:p>
-            <a:pPr marL="1087438" lvl="0" indent="-1087438" eaLnBrk="0" fontAlgn="base" hangingPunct="0">
+            <a:pPr marL="1087755" lvl="0" indent="-1087755" eaLnBrk="0" fontAlgn="base" hangingPunct="0">
               <a:lnSpc>
                 <a:spcPct val="150000"/>
               </a:lnSpc>
@@ -2763,7 +2509,7 @@
                 <a:effectLst/>
                 <a:uLnTx/>
                 <a:uFillTx/>
-                <a:ea typeface="SimSun" charset="0"/>
+                <a:ea typeface="SimSun" panose="02010600030101010101" pitchFamily="2" charset="-122"/>
                 <a:cs typeface="Calibri" panose="020F0502020204030204" pitchFamily="34" charset="0"/>
               </a:rPr>
               <a:t>REP. OFFICE</a:t>
@@ -2773,7 +2519,7 @@
                 <a:solidFill>
                   <a:srgbClr val="002060"/>
                 </a:solidFill>
-                <a:ea typeface="SimSun" charset="0"/>
+                <a:ea typeface="SimSun" panose="02010600030101010101" pitchFamily="2" charset="-122"/>
                 <a:cs typeface="Calibri" panose="020F0502020204030204" pitchFamily="34" charset="0"/>
               </a:rPr>
               <a:t>:</a:t>
@@ -2784,7 +2530,7 @@
                   <a:srgbClr val="002060"/>
                 </a:solidFill>
                 <a:latin typeface="+mj-lt"/>
-                <a:ea typeface="SimSun" charset="0"/>
+                <a:ea typeface="SimSun" panose="02010600030101010101" pitchFamily="2" charset="-122"/>
                 <a:cs typeface="Calibri" panose="020F0502020204030204" pitchFamily="34" charset="0"/>
               </a:rPr>
               <a:t> </a:t>
@@ -2797,7 +2543,7 @@
                   </a:srgbClr>
                 </a:solidFill>
                 <a:latin typeface="+mj-lt"/>
-                <a:ea typeface="SimSun" charset="0"/>
+                <a:ea typeface="SimSun" panose="02010600030101010101" pitchFamily="2" charset="-122"/>
                 <a:cs typeface="Calibri" panose="020F0502020204030204" pitchFamily="34" charset="0"/>
               </a:rPr>
               <a:t>	</a:t>
@@ -2808,9 +2554,12 @@
               </a:rPr>
               <a:t>2A Phan Ke Binh, Tan Dinh Ward, Ho Chi Minh City, Viet Nam</a:t>
             </a:r>
+            <a:endParaRPr lang="en-US" sz="1200" b="1" dirty="0">
+              <a:latin typeface="+mj-lt"/>
+            </a:endParaRPr>
           </a:p>
           <a:p>
-            <a:pPr marL="1087438" lvl="0" indent="-1087438" eaLnBrk="0" fontAlgn="base" hangingPunct="0">
+            <a:pPr marL="1087755" lvl="0" indent="-1087755" eaLnBrk="0" fontAlgn="base" hangingPunct="0">
               <a:lnSpc>
                 <a:spcPct val="150000"/>
               </a:lnSpc>
@@ -2830,7 +2579,7 @@
                 <a:solidFill>
                   <a:srgbClr val="002060"/>
                 </a:solidFill>
-                <a:ea typeface="SimSun" charset="0"/>
+                <a:ea typeface="SimSun" panose="02010600030101010101" pitchFamily="2" charset="-122"/>
                 <a:cs typeface="Calibri" panose="020F0502020204030204" pitchFamily="34" charset="0"/>
               </a:rPr>
               <a:t>FACTORY 1:</a:t>
@@ -2842,7 +2591,7 @@
                     <a:lumMod val="50000"/>
                   </a:srgbClr>
                 </a:solidFill>
-                <a:ea typeface="SimSun" charset="0"/>
+                <a:ea typeface="SimSun" panose="02010600030101010101" pitchFamily="2" charset="-122"/>
                 <a:cs typeface="Calibri" panose="020F0502020204030204" pitchFamily="34" charset="0"/>
               </a:rPr>
               <a:t>	</a:t>
@@ -2853,13 +2602,20 @@
                   <a:prstClr val="black"/>
                 </a:solidFill>
                 <a:latin typeface="+mj-lt"/>
-                <a:ea typeface="SimSun" charset="0"/>
+                <a:ea typeface="SimSun" panose="02010600030101010101" pitchFamily="2" charset="-122"/>
               </a:rPr>
               <a:t>Hoa Trung Industrial Zone, Hoa Trung Hamlet, Luong The Tran Commune, Ca Mau Province, Viet Nam</a:t>
             </a:r>
+            <a:endParaRPr lang="en-US" sz="1200" b="1" dirty="0">
+              <a:solidFill>
+                <a:prstClr val="black"/>
+              </a:solidFill>
+              <a:latin typeface="+mj-lt"/>
+              <a:ea typeface="SimSun" panose="02010600030101010101" pitchFamily="2" charset="-122"/>
+            </a:endParaRPr>
           </a:p>
           <a:p>
-            <a:pPr marL="1087438" lvl="0" indent="-1087438" eaLnBrk="0" fontAlgn="base" hangingPunct="0">
+            <a:pPr marL="1087755" lvl="0" indent="-1087755" eaLnBrk="0" fontAlgn="base" hangingPunct="0">
               <a:lnSpc>
                 <a:spcPct val="150000"/>
               </a:lnSpc>
@@ -2879,7 +2635,7 @@
                 <a:solidFill>
                   <a:srgbClr val="002060"/>
                 </a:solidFill>
-                <a:ea typeface="SimSun" charset="0"/>
+                <a:ea typeface="SimSun" panose="02010600030101010101" pitchFamily="2" charset="-122"/>
                 <a:cs typeface="Calibri" panose="020F0502020204030204" pitchFamily="34" charset="0"/>
               </a:rPr>
               <a:t>FACTORY 2:</a:t>
@@ -2889,7 +2645,7 @@
                 <a:solidFill>
                   <a:srgbClr val="002060"/>
                 </a:solidFill>
-                <a:ea typeface="SimSun" charset="0"/>
+                <a:ea typeface="SimSun" panose="02010600030101010101" pitchFamily="2" charset="-122"/>
                 <a:cs typeface="Calibri" panose="020F0502020204030204" pitchFamily="34" charset="0"/>
               </a:rPr>
               <a:t> </a:t>
@@ -2901,7 +2657,7 @@
                     <a:lumMod val="50000"/>
                   </a:srgbClr>
                 </a:solidFill>
-                <a:ea typeface="SimSun" charset="0"/>
+                <a:ea typeface="SimSun" panose="02010600030101010101" pitchFamily="2" charset="-122"/>
                 <a:cs typeface="Calibri" panose="020F0502020204030204" pitchFamily="34" charset="0"/>
               </a:rPr>
               <a:t>	</a:t>
@@ -2912,7 +2668,7 @@
                   <a:prstClr val="black"/>
                 </a:solidFill>
                 <a:latin typeface="+mj-lt"/>
-                <a:ea typeface="SimSun" charset="0"/>
+                <a:ea typeface="SimSun" panose="02010600030101010101" pitchFamily="2" charset="-122"/>
               </a:rPr>
               <a:t>Song Hau Industrial Park, Chau Thanh Commune, Can Tho City, Viet Nam</a:t>
             </a:r>
@@ -2921,11 +2677,11 @@
                 <a:srgbClr val="002060"/>
               </a:solidFill>
               <a:latin typeface="+mj-lt"/>
-              <a:ea typeface="SimSun" charset="0"/>
+              <a:ea typeface="SimSun" panose="02010600030101010101" pitchFamily="2" charset="-122"/>
             </a:endParaRPr>
           </a:p>
           <a:p>
-            <a:pPr marL="1087438" lvl="0" indent="-1087438" eaLnBrk="0" fontAlgn="base" hangingPunct="0">
+            <a:pPr marL="1087755" lvl="0" indent="-1087755" eaLnBrk="0" fontAlgn="base" hangingPunct="0">
               <a:lnSpc>
                 <a:spcPct val="150000"/>
               </a:lnSpc>
@@ -2945,7 +2701,7 @@
                 <a:solidFill>
                   <a:srgbClr val="002060"/>
                 </a:solidFill>
-                <a:ea typeface="SimSun" charset="0"/>
+                <a:ea typeface="SimSun" panose="02010600030101010101" pitchFamily="2" charset="-122"/>
                 <a:cs typeface="Calibri" panose="020F0502020204030204" pitchFamily="34" charset="0"/>
                 <a:sym typeface="Wingdings" panose="05000000000000000000" pitchFamily="2" charset="2"/>
               </a:rPr>
@@ -2957,14 +2713,22 @@
                   <a:prstClr val="black"/>
                 </a:solidFill>
                 <a:latin typeface="+mj-lt"/>
-                <a:ea typeface="SimSun" charset="0"/>
+                <a:ea typeface="SimSun" panose="02010600030101010101" pitchFamily="2" charset="-122"/>
                 <a:sym typeface="Wingdings" panose="05000000000000000000" pitchFamily="2" charset="2"/>
               </a:rPr>
               <a:t>	(+84) 28 3911 2183</a:t>
             </a:r>
+            <a:endParaRPr lang="en-US" sz="1200" b="1" dirty="0">
+              <a:solidFill>
+                <a:prstClr val="black"/>
+              </a:solidFill>
+              <a:latin typeface="+mj-lt"/>
+              <a:ea typeface="SimSun" panose="02010600030101010101" pitchFamily="2" charset="-122"/>
+              <a:sym typeface="Wingdings" panose="05000000000000000000" pitchFamily="2" charset="2"/>
+            </a:endParaRPr>
           </a:p>
           <a:p>
-            <a:pPr marL="1087438" lvl="0" indent="-1087438" eaLnBrk="0" fontAlgn="base" hangingPunct="0">
+            <a:pPr marL="1087755" lvl="0" indent="-1087755" eaLnBrk="0" fontAlgn="base" hangingPunct="0">
               <a:lnSpc>
                 <a:spcPct val="150000"/>
               </a:lnSpc>
@@ -2984,7 +2748,7 @@
                 <a:solidFill>
                   <a:srgbClr val="002060"/>
                 </a:solidFill>
-                <a:ea typeface="SimSun" charset="0"/>
+                <a:ea typeface="SimSun" panose="02010600030101010101" pitchFamily="2" charset="-122"/>
                 <a:cs typeface="Calibri" panose="020F0502020204030204" pitchFamily="34" charset="0"/>
                 <a:sym typeface="Wingdings" panose="05000000000000000000" pitchFamily="2" charset="2"/>
               </a:rPr>
@@ -2996,36 +2760,38 @@
                   <a:prstClr val="black"/>
                 </a:solidFill>
                 <a:latin typeface="+mj-lt"/>
-                <a:ea typeface="SimSun" charset="0"/>
+                <a:ea typeface="SimSun" panose="02010600030101010101" pitchFamily="2" charset="-122"/>
                 <a:sym typeface="Wingdings" panose="05000000000000000000" pitchFamily="2" charset="2"/>
               </a:rPr>
               <a:t>	www.vnfoods.vn</a:t>
             </a:r>
+            <a:endParaRPr lang="en-US" sz="1200" b="1" dirty="0">
+              <a:solidFill>
+                <a:prstClr val="black"/>
+              </a:solidFill>
+              <a:latin typeface="+mj-lt"/>
+              <a:ea typeface="SimSun" panose="02010600030101010101" pitchFamily="2" charset="-122"/>
+              <a:sym typeface="Wingdings" panose="05000000000000000000" pitchFamily="2" charset="2"/>
+            </a:endParaRPr>
           </a:p>
         </p:txBody>
       </p:sp>
       <p:pic>
         <p:nvPicPr>
-          <p:cNvPr id="8" name="Graphic 7" descr="Factory">
-            <a:extLst>
-              <a:ext uri="{FF2B5EF4-FFF2-40B4-BE49-F238E27FC236}">
-                <a16:creationId xmlns:a16="http://schemas.microsoft.com/office/drawing/2014/main" id="{F1701C2C-FCA9-4613-B397-D9944D2F31BC}"/>
-              </a:ext>
-            </a:extLst>
-          </p:cNvPr>
+          <p:cNvPr id="8" name="Graphic 7" descr="Factory"/>
           <p:cNvPicPr>
             <a:picLocks noChangeAspect="1"/>
           </p:cNvPicPr>
           <p:nvPr/>
         </p:nvPicPr>
         <p:blipFill>
-          <a:blip cstate="print">
+          <a:blip r:embed="rId7" cstate="print">
             <a:extLst>
               <a:ext uri="{28A0092B-C50C-407E-A947-70E740481C1C}">
                 <a14:useLocalDpi xmlns:a14="http://schemas.microsoft.com/office/drawing/2010/main" val="0"/>
               </a:ext>
               <a:ext uri="{96DAC541-7B7A-43D3-8B79-37D633B846F1}">
-                <asvg:svgBlip xmlns:asvg="http://schemas.microsoft.com/office/drawing/2016/SVG/main" r:embed="rId9"/>
+                <asvg:svgBlip xmlns:asvg="http://schemas.microsoft.com/office/drawing/2016/SVG/main" r:embed="rId8"/>
               </a:ext>
             </a:extLst>
           </a:blip>
@@ -3045,20 +2811,14 @@
       </p:pic>
       <p:pic>
         <p:nvPicPr>
-          <p:cNvPr id="12" name="Graphic 11" descr="Schoolhouse">
-            <a:extLst>
-              <a:ext uri="{FF2B5EF4-FFF2-40B4-BE49-F238E27FC236}">
-                <a16:creationId xmlns:a16="http://schemas.microsoft.com/office/drawing/2014/main" id="{E8028E59-1986-430F-AA8F-B697B2D96C5B}"/>
-              </a:ext>
-            </a:extLst>
-          </p:cNvPr>
+          <p:cNvPr id="12" name="Graphic 11" descr="Schoolhouse"/>
           <p:cNvPicPr>
             <a:picLocks noChangeAspect="1"/>
           </p:cNvPicPr>
           <p:nvPr/>
         </p:nvPicPr>
         <p:blipFill>
-          <a:blip cstate="print">
+          <a:blip r:embed="rId9" cstate="print">
             <a:extLst>
               <a:ext uri="{28A0092B-C50C-407E-A947-70E740481C1C}">
                 <a14:useLocalDpi xmlns:a14="http://schemas.microsoft.com/office/drawing/2010/main" val="0"/>
@@ -3084,26 +2844,20 @@
       </p:pic>
       <p:pic>
         <p:nvPicPr>
-          <p:cNvPr id="15" name="Graphic 14" descr="Telephone">
-            <a:extLst>
-              <a:ext uri="{FF2B5EF4-FFF2-40B4-BE49-F238E27FC236}">
-                <a16:creationId xmlns:a16="http://schemas.microsoft.com/office/drawing/2014/main" id="{C94010AA-490E-48EA-8539-85E8F074CAF6}"/>
-              </a:ext>
-            </a:extLst>
-          </p:cNvPr>
+          <p:cNvPr id="15" name="Graphic 14" descr="Telephone"/>
           <p:cNvPicPr>
             <a:picLocks noChangeAspect="1"/>
           </p:cNvPicPr>
           <p:nvPr/>
         </p:nvPicPr>
         <p:blipFill>
-          <a:blip cstate="print">
+          <a:blip r:embed="rId11" cstate="print">
             <a:extLst>
               <a:ext uri="{28A0092B-C50C-407E-A947-70E740481C1C}">
                 <a14:useLocalDpi xmlns:a14="http://schemas.microsoft.com/office/drawing/2010/main" val="0"/>
               </a:ext>
               <a:ext uri="{96DAC541-7B7A-43D3-8B79-37D633B846F1}">
-                <asvg:svgBlip xmlns:asvg="http://schemas.microsoft.com/office/drawing/2016/SVG/main" r:embed="rId11"/>
+                <asvg:svgBlip xmlns:asvg="http://schemas.microsoft.com/office/drawing/2016/SVG/main" r:embed="rId12"/>
               </a:ext>
             </a:extLst>
           </a:blip>
@@ -3123,26 +2877,20 @@
       </p:pic>
       <p:pic>
         <p:nvPicPr>
-          <p:cNvPr id="18" name="Graphic 17" descr="World">
-            <a:extLst>
-              <a:ext uri="{FF2B5EF4-FFF2-40B4-BE49-F238E27FC236}">
-                <a16:creationId xmlns:a16="http://schemas.microsoft.com/office/drawing/2014/main" id="{57314E18-8B55-4E84-9F14-1C24B3FEA1D2}"/>
-              </a:ext>
-            </a:extLst>
-          </p:cNvPr>
+          <p:cNvPr id="18" name="Graphic 17" descr="World"/>
           <p:cNvPicPr>
             <a:picLocks noChangeAspect="1"/>
           </p:cNvPicPr>
           <p:nvPr/>
         </p:nvPicPr>
         <p:blipFill>
-          <a:blip cstate="print">
+          <a:blip r:embed="rId13" cstate="print">
             <a:extLst>
               <a:ext uri="{28A0092B-C50C-407E-A947-70E740481C1C}">
                 <a14:useLocalDpi xmlns:a14="http://schemas.microsoft.com/office/drawing/2010/main" val="0"/>
               </a:ext>
               <a:ext uri="{96DAC541-7B7A-43D3-8B79-37D633B846F1}">
-                <asvg:svgBlip xmlns:asvg="http://schemas.microsoft.com/office/drawing/2016/SVG/main" r:embed="rId12"/>
+                <asvg:svgBlip xmlns:asvg="http://schemas.microsoft.com/office/drawing/2016/SVG/main" r:embed="rId14"/>
               </a:ext>
             </a:extLst>
           </a:blip>
@@ -3162,26 +2910,20 @@
       </p:pic>
       <p:pic>
         <p:nvPicPr>
-          <p:cNvPr id="26" name="Graphic 25" descr="Factory">
-            <a:extLst>
-              <a:ext uri="{FF2B5EF4-FFF2-40B4-BE49-F238E27FC236}">
-                <a16:creationId xmlns:a16="http://schemas.microsoft.com/office/drawing/2014/main" id="{C21120E8-CE7A-4DC7-8A10-CECA16AE2DB1}"/>
-              </a:ext>
-            </a:extLst>
-          </p:cNvPr>
+          <p:cNvPr id="26" name="Graphic 25" descr="Factory"/>
           <p:cNvPicPr>
             <a:picLocks noChangeAspect="1"/>
           </p:cNvPicPr>
           <p:nvPr/>
         </p:nvPicPr>
         <p:blipFill>
-          <a:blip cstate="print">
+          <a:blip r:embed="rId7" cstate="print">
             <a:extLst>
               <a:ext uri="{28A0092B-C50C-407E-A947-70E740481C1C}">
                 <a14:useLocalDpi xmlns:a14="http://schemas.microsoft.com/office/drawing/2010/main" val="0"/>
               </a:ext>
               <a:ext uri="{96DAC541-7B7A-43D3-8B79-37D633B846F1}">
-                <asvg:svgBlip xmlns:asvg="http://schemas.microsoft.com/office/drawing/2016/SVG/main" r:embed="rId9"/>
+                <asvg:svgBlip xmlns:asvg="http://schemas.microsoft.com/office/drawing/2016/SVG/main" r:embed="rId8"/>
               </a:ext>
             </a:extLst>
           </a:blip>
@@ -3201,28 +2943,18 @@
       </p:pic>
       <p:pic>
         <p:nvPicPr>
-          <p:cNvPr id="4" name="Picture 3">
-            <a:extLst>
-              <a:ext uri="{FF2B5EF4-FFF2-40B4-BE49-F238E27FC236}">
-                <a16:creationId xmlns:a16="http://schemas.microsoft.com/office/drawing/2014/main" id="{01EB88A8-D077-4F05-A5AC-47944B6EB518}"/>
-              </a:ext>
-            </a:extLst>
-          </p:cNvPr>
+          <p:cNvPr id="4" name="Picture 3"/>
           <p:cNvPicPr>
             <a:picLocks noChangeAspect="1"/>
           </p:cNvPicPr>
           <p:nvPr/>
         </p:nvPicPr>
         <p:blipFill rotWithShape="1">
-          <a:blip r:embed="rId13" cstate="print">
-            <a:extLst>
-              <a:ext uri="{28A0092B-C50C-407E-A947-70E740481C1C}">
-                <a14:useLocalDpi xmlns:a14="http://schemas.microsoft.com/office/drawing/2010/main"/>
-              </a:ext>
-            </a:extLst>
-          </a:blip>
+          <a:blip r:embed="rId15" cstate="print"/>
           <a:srcRect/>
-          <a:stretch/>
+          <a:stretch>
+            <a:fillRect/>
+          </a:stretch>
         </p:blipFill>
         <p:spPr>
           <a:xfrm>
@@ -3236,13 +2968,7 @@
       </p:pic>
       <p:sp>
         <p:nvSpPr>
-          <p:cNvPr id="5" name="Rectangle 4">
-            <a:extLst>
-              <a:ext uri="{FF2B5EF4-FFF2-40B4-BE49-F238E27FC236}">
-                <a16:creationId xmlns:a16="http://schemas.microsoft.com/office/drawing/2014/main" id="{44575D57-F6A7-410B-B28B-E6AE47E9F3BE}"/>
-              </a:ext>
-            </a:extLst>
-          </p:cNvPr>
+          <p:cNvPr id="5" name="Rectangle 4"/>
           <p:cNvSpPr/>
           <p:nvPr/>
         </p:nvSpPr>
@@ -3292,31 +3018,34 @@
               </a:rPr>
               <a:t>Confidential</a:t>
             </a:r>
+            <a:endParaRPr lang="en-US" sz="1200" b="1">
+              <a:solidFill>
+                <a:schemeClr val="tx1">
+                  <a:lumMod val="65000"/>
+                  <a:lumOff val="35000"/>
+                </a:schemeClr>
+              </a:solidFill>
+              <a:latin typeface="+mj-lt"/>
+            </a:endParaRPr>
           </a:p>
         </p:txBody>
       </p:sp>
       <p:pic>
         <p:nvPicPr>
-          <p:cNvPr id="6" name="Picture 5">
-            <a:extLst>
-              <a:ext uri="{FF2B5EF4-FFF2-40B4-BE49-F238E27FC236}">
-                <a16:creationId xmlns:a16="http://schemas.microsoft.com/office/drawing/2014/main" id="{0262679C-E6DE-48ED-AA00-619B4E15E83B}"/>
-              </a:ext>
-            </a:extLst>
-          </p:cNvPr>
+          <p:cNvPr id="6" name="Picture 5"/>
           <p:cNvPicPr>
             <a:picLocks noChangeAspect="1"/>
           </p:cNvPicPr>
           <p:nvPr/>
         </p:nvPicPr>
         <p:blipFill>
-          <a:blip r:embed="rId14" cstate="print">
+          <a:blip r:embed="rId16" cstate="print">
             <a:extLst>
               <a:ext uri="{BEBA8EAE-BF5A-486C-A8C5-ECC9F3942E4B}">
                 <a14:imgProps xmlns:a14="http://schemas.microsoft.com/office/drawing/2010/main">
-                  <a14:imgLayer r:embed="rId15">
+                  <a14:imgLayer r:embed="rId17">
                     <a14:imgEffect>
-                      <a14:sharpenSoften amount="50000"/>
+                      <a14:brightnessContrast bright="5000" contrast="5000"/>
                     </a14:imgEffect>
                     <a14:imgEffect>
                       <a14:colorTemperature colorTemp="11200"/>
@@ -3325,13 +3054,10 @@
                       <a14:saturation sat="200000"/>
                     </a14:imgEffect>
                     <a14:imgEffect>
-                      <a14:brightnessContrast bright="5000" contrast="5000"/>
+                      <a14:sharpenSoften amount="50000"/>
                     </a14:imgEffect>
                   </a14:imgLayer>
                 </a14:imgProps>
-              </a:ext>
-              <a:ext uri="{28A0092B-C50C-407E-A947-70E740481C1C}">
-                <a14:useLocalDpi xmlns:a14="http://schemas.microsoft.com/office/drawing/2010/main"/>
               </a:ext>
             </a:extLst>
           </a:blip>
@@ -3357,132 +3083,6 @@
         </p:spPr>
       </p:pic>
     </p:spTree>
-    <p:extLst>
-      <p:ext uri="{BB962C8B-B14F-4D97-AF65-F5344CB8AC3E}">
-        <p14:creationId xmlns:p14="http://schemas.microsoft.com/office/powerpoint/2010/main" val="3712163682"/>
-      </p:ext>
-    </p:extLst>
-  </p:cSld>
-  <p:clrMapOvr>
-    <a:masterClrMapping/>
-  </p:clrMapOvr>
-</p:sld>
-</file>
-
-<file path=ppt/slides/slide2.xml><?xml version="1.0" encoding="utf-8"?>
-<p:sld xmlns:a="http://schemas.openxmlformats.org/drawingml/2006/main" xmlns:r="http://schemas.openxmlformats.org/officeDocument/2006/relationships" xmlns:p="http://schemas.openxmlformats.org/presentationml/2006/main">
-  <p:cSld>
-    <p:spTree>
-      <p:nvGrpSpPr>
-        <p:cNvPr id="1" name=""/>
-        <p:cNvGrpSpPr/>
-        <p:nvPr/>
-      </p:nvGrpSpPr>
-      <p:grpSpPr>
-        <a:xfrm>
-          <a:off x="0" y="0"/>
-          <a:ext cx="0" cy="0"/>
-          <a:chOff x="0" y="0"/>
-          <a:chExt cx="0" cy="0"/>
-        </a:xfrm>
-      </p:grpSpPr>
-      <p:sp>
-        <p:nvSpPr>
-          <p:cNvPr id="2" name="Title 1">
-            <a:extLst>
-              <a:ext uri="{FF2B5EF4-FFF2-40B4-BE49-F238E27FC236}">
-                <a16:creationId xmlns:a16="http://schemas.microsoft.com/office/drawing/2014/main" id="{1B55BBBB-735D-423D-8CA4-44631BD99D96}"/>
-              </a:ext>
-            </a:extLst>
-          </p:cNvPr>
-          <p:cNvSpPr>
-            <a:spLocks noGrp="1"/>
-          </p:cNvSpPr>
-          <p:nvPr>
-            <p:ph type="title"/>
-          </p:nvPr>
-        </p:nvSpPr>
-        <p:spPr>
-          <a:xfrm>
-            <a:off x="89076" y="89032"/>
-            <a:ext cx="8919466" cy="658023"/>
-          </a:xfrm>
-        </p:spPr>
-        <p:txBody>
-          <a:bodyPr>
-            <a:normAutofit/>
-          </a:bodyPr>
-          <a:lstStyle/>
-          <a:p>
-            <a:r>
-              <a:rPr lang="vi-VN" dirty="0"/>
-              <a:t>[</a:t>
-            </a:r>
-            <a:r>
-              <a:rPr lang="vi-VN" sz="2000" dirty="0">
-                <a:latin typeface="Montserrat" pitchFamily="2" charset="77"/>
-              </a:rPr>
-              <a:t>Header]</a:t>
-            </a:r>
-            <a:endParaRPr lang="en-US" sz="2000" dirty="0">
-              <a:latin typeface="Montserrat" pitchFamily="2" charset="77"/>
-            </a:endParaRPr>
-          </a:p>
-        </p:txBody>
-      </p:sp>
-      <p:sp>
-        <p:nvSpPr>
-          <p:cNvPr id="3" name="Slide Number Placeholder 2">
-            <a:extLst>
-              <a:ext uri="{FF2B5EF4-FFF2-40B4-BE49-F238E27FC236}">
-                <a16:creationId xmlns:a16="http://schemas.microsoft.com/office/drawing/2014/main" id="{4AD03A3E-CC63-47D2-8092-3DABCD88BF69}"/>
-              </a:ext>
-            </a:extLst>
-          </p:cNvPr>
-          <p:cNvSpPr>
-            <a:spLocks noGrp="1"/>
-          </p:cNvSpPr>
-          <p:nvPr>
-            <p:ph type="sldNum" sz="quarter" idx="4"/>
-          </p:nvPr>
-        </p:nvSpPr>
-        <p:spPr>
-          <a:xfrm>
-            <a:off x="6874941" y="6516531"/>
-            <a:ext cx="2133600" cy="252436"/>
-          </a:xfrm>
-        </p:spPr>
-        <p:txBody>
-          <a:bodyPr/>
-          <a:lstStyle/>
-          <a:p>
-            <a:fld id="{3AA9C925-62A8-4F0C-A636-02F5BEC7D3B0}" type="slidenum">
-              <a:rPr lang="en-US" smtClean="0">
-                <a:solidFill>
-                  <a:prstClr val="black">
-                    <a:tint val="75000"/>
-                  </a:prstClr>
-                </a:solidFill>
-              </a:rPr>
-              <a:pPr/>
-              <a:t>2</a:t>
-            </a:fld>
-            <a:endParaRPr lang="en-US">
-              <a:solidFill>
-                <a:prstClr val="black">
-                  <a:tint val="75000"/>
-                </a:prstClr>
-              </a:solidFill>
-            </a:endParaRPr>
-          </a:p>
-        </p:txBody>
-      </p:sp>
-    </p:spTree>
-    <p:extLst>
-      <p:ext uri="{BB962C8B-B14F-4D97-AF65-F5344CB8AC3E}">
-        <p14:creationId xmlns:p14="http://schemas.microsoft.com/office/powerpoint/2010/main" val="3893268373"/>
-      </p:ext>
-    </p:extLst>
   </p:cSld>
   <p:clrMapOvr>
     <a:masterClrMapping/>
@@ -3491,20 +3091,20 @@
 </file>
 
 <file path=ppt/tags/tag1.xml><?xml version="1.0" encoding="utf-8"?>
-<p:tagLst xmlns:a="http://schemas.openxmlformats.org/drawingml/2006/main" xmlns:r="http://schemas.openxmlformats.org/officeDocument/2006/relationships" xmlns:p="http://schemas.openxmlformats.org/presentationml/2006/main">
-  <p:tag name="DH_FLYSHEET_STYLE" val="1"/>
+<p:tagLst xmlns:p="http://schemas.openxmlformats.org/presentationml/2006/main">
+  <p:tag name="MM_SLIDE_TYPE" val="6"/>
 </p:tagLst>
 </file>
 
 <file path=ppt/tags/tag2.xml><?xml version="1.0" encoding="utf-8"?>
-<p:tagLst xmlns:a="http://schemas.openxmlformats.org/drawingml/2006/main" xmlns:r="http://schemas.openxmlformats.org/officeDocument/2006/relationships" xmlns:p="http://schemas.openxmlformats.org/presentationml/2006/main">
+<p:tagLst xmlns:p="http://schemas.openxmlformats.org/presentationml/2006/main">
   <p:tag name="MM_SLIDE_TYPE" val="6"/>
 </p:tagLst>
 </file>
 
-<file path=ppt/tags/tag3.xml><?xml version="1.0" encoding="utf-8"?>
-<p:tagLst xmlns:a="http://schemas.openxmlformats.org/drawingml/2006/main" xmlns:r="http://schemas.openxmlformats.org/officeDocument/2006/relationships" xmlns:p="http://schemas.openxmlformats.org/presentationml/2006/main">
-  <p:tag name="MM_SLIDE_TYPE" val="6"/>
+<file path=ppt/tags/tag6.xml><?xml version="1.0" encoding="utf-8"?>
+<p:tagLst xmlns:p="http://schemas.openxmlformats.org/presentationml/2006/main">
+  <p:tag name="DH_FLYSHEET_STYLE" val="1"/>
 </p:tagLst>
 </file>
 
@@ -3770,7 +3370,11 @@
       </a:style>
     </a:spDef>
   </a:objectDefaults>
-  <a:extraClrSchemeLst/>
+  <a:extLst>
+    <a:ext uri="{05A4C25C-085E-4340-85A3-A5531E510DB2}">
+      <thm15:themeFamily xmlns:thm15="http://schemas.microsoft.com/office/thememl/2012/main" name="Office Theme" id="{62F939B6-93AF-4DB8-9C6B-D6C7DFDC589F}" vid="{4A3C46E8-61CC-4603-A589-7422A47A8E4A}"/>
+    </a:ext>
+  </a:extLst>
 </a:theme>
 </file>
 
@@ -3817,7 +3421,7 @@
     </a:clrScheme>
     <a:fontScheme name="Office">
       <a:majorFont>
-        <a:latin typeface="Calibri Light" panose="020F0302020204030204"/>
+        <a:latin typeface="Calibri Light"/>
         <a:ea typeface=""/>
         <a:cs typeface=""/>
         <a:font script="Jpan" typeface="ＭＳ Ｐゴシック"/>
@@ -3852,7 +3456,7 @@
         <a:font script="Geor" typeface="Sylfaen"/>
       </a:majorFont>
       <a:minorFont>
-        <a:latin typeface="Calibri" panose="020F0502020204030204"/>
+        <a:latin typeface="Calibri"/>
         <a:ea typeface=""/>
         <a:cs typeface=""/>
         <a:font script="Jpan" typeface="ＭＳ Ｐゴシック"/>
@@ -4025,8 +3629,6 @@
       </a:bgFillStyleLst>
     </a:fmtScheme>
   </a:themeElements>
-  <a:objectDefaults/>
-  <a:extraClrSchemeLst/>
   <a:extLst>
     <a:ext uri="{05A4C25C-085E-4340-85A3-A5531E510DB2}">
       <thm15:themeFamily xmlns:thm15="http://schemas.microsoft.com/office/thememl/2012/main" name="Office Theme" id="{62F939B6-93AF-4DB8-9C6B-D6C7DFDC589F}" vid="{4A3C46E8-61CC-4603-A589-7422A47A8E4A}"/>
@@ -4078,7 +3680,7 @@
     </a:clrScheme>
     <a:fontScheme name="Office">
       <a:majorFont>
-        <a:latin typeface="Calibri Light" panose="020F0302020204030204"/>
+        <a:latin typeface="Calibri Light"/>
         <a:ea typeface=""/>
         <a:cs typeface=""/>
         <a:font script="Jpan" typeface="游ゴシック Light"/>
@@ -4111,26 +3713,9 @@
         <a:font script="Viet" typeface="Times New Roman"/>
         <a:font script="Uigh" typeface="Microsoft Uighur"/>
         <a:font script="Geor" typeface="Sylfaen"/>
-        <a:font script="Armn" typeface="Arial"/>
-        <a:font script="Bugi" typeface="Leelawadee UI"/>
-        <a:font script="Bopo" typeface="Microsoft JhengHei"/>
-        <a:font script="Java" typeface="Javanese Text"/>
-        <a:font script="Lisu" typeface="Segoe UI"/>
-        <a:font script="Mymr" typeface="Myanmar Text"/>
-        <a:font script="Nkoo" typeface="Ebrima"/>
-        <a:font script="Olck" typeface="Nirmala UI"/>
-        <a:font script="Osma" typeface="Ebrima"/>
-        <a:font script="Phag" typeface="Phagspa"/>
-        <a:font script="Syrn" typeface="Estrangelo Edessa"/>
-        <a:font script="Syrj" typeface="Estrangelo Edessa"/>
-        <a:font script="Syre" typeface="Estrangelo Edessa"/>
-        <a:font script="Sora" typeface="Nirmala UI"/>
-        <a:font script="Tale" typeface="Microsoft Tai Le"/>
-        <a:font script="Talu" typeface="Microsoft New Tai Lue"/>
-        <a:font script="Tfng" typeface="Ebrima"/>
       </a:majorFont>
       <a:minorFont>
-        <a:latin typeface="Calibri" panose="020F0502020204030204"/>
+        <a:latin typeface="Calibri"/>
         <a:ea typeface=""/>
         <a:cs typeface=""/>
         <a:font script="Jpan" typeface="游ゴシック"/>
@@ -4163,23 +3748,6 @@
         <a:font script="Viet" typeface="Arial"/>
         <a:font script="Uigh" typeface="Microsoft Uighur"/>
         <a:font script="Geor" typeface="Sylfaen"/>
-        <a:font script="Armn" typeface="Arial"/>
-        <a:font script="Bugi" typeface="Leelawadee UI"/>
-        <a:font script="Bopo" typeface="Microsoft JhengHei"/>
-        <a:font script="Java" typeface="Javanese Text"/>
-        <a:font script="Lisu" typeface="Segoe UI"/>
-        <a:font script="Mymr" typeface="Myanmar Text"/>
-        <a:font script="Nkoo" typeface="Ebrima"/>
-        <a:font script="Olck" typeface="Nirmala UI"/>
-        <a:font script="Osma" typeface="Ebrima"/>
-        <a:font script="Phag" typeface="Phagspa"/>
-        <a:font script="Syrn" typeface="Estrangelo Edessa"/>
-        <a:font script="Syrj" typeface="Estrangelo Edessa"/>
-        <a:font script="Syre" typeface="Estrangelo Edessa"/>
-        <a:font script="Sora" typeface="Nirmala UI"/>
-        <a:font script="Tale" typeface="Microsoft Tai Le"/>
-        <a:font script="Talu" typeface="Microsoft New Tai Lue"/>
-        <a:font script="Tfng" typeface="Ebrima"/>
       </a:minorFont>
     </a:fontScheme>
     <a:fmtScheme name="Office">
@@ -4320,8 +3888,6 @@
       </a:bgFillStyleLst>
     </a:fmtScheme>
   </a:themeElements>
-  <a:objectDefaults/>
-  <a:extraClrSchemeLst/>
   <a:extLst>
     <a:ext uri="{05A4C25C-085E-4340-85A3-A5531E510DB2}">
       <thm15:themeFamily xmlns:thm15="http://schemas.microsoft.com/office/thememl/2012/main" name="Office Theme" id="{62F939B6-93AF-4DB8-9C6B-D6C7DFDC589F}" vid="{4A3C46E8-61CC-4603-A589-7422A47A8E4A}"/>
@@ -4611,40 +4177,20 @@
 </FormTemplates>
 </file>
 
-<file path=customXml/itemProps1.xml><?xml version="1.0" encoding="utf-8"?>
+<file path=customXml/itemProps3.xml><?xml version="1.0" encoding="utf-8"?>
 <ds:datastoreItem xmlns:ds="http://schemas.openxmlformats.org/officeDocument/2006/customXml" ds:itemID="{05064457-A99B-4F5A-8265-53D78F6EBD13}">
-  <ds:schemaRefs>
-    <ds:schemaRef ds:uri="http://schemas.microsoft.com/office/2006/metadata/contentType"/>
-    <ds:schemaRef ds:uri="http://schemas.microsoft.com/office/2006/metadata/properties/metaAttributes"/>
-    <ds:schemaRef ds:uri="http://www.w3.org/2001/XMLSchema"/>
-    <ds:schemaRef ds:uri="http://schemas.microsoft.com/office/2006/metadata/properties"/>
-    <ds:schemaRef ds:uri="bd46642e-baf8-4e0b-90a8-08a61c43d436"/>
-    <ds:schemaRef ds:uri="da89c8aa-bdf1-4272-829d-0bf2fbc1fefc"/>
-    <ds:schemaRef ds:uri="http://schemas.microsoft.com/office/2006/documentManagement/types"/>
-    <ds:schemaRef ds:uri="http://schemas.microsoft.com/office/infopath/2007/PartnerControls"/>
-    <ds:schemaRef ds:uri="http://schemas.openxmlformats.org/package/2006/metadata/core-properties"/>
-    <ds:schemaRef ds:uri="http://purl.org/dc/elements/1.1/"/>
-    <ds:schemaRef ds:uri="http://purl.org/dc/terms/"/>
-    <ds:schemaRef ds:uri="http://schemas.microsoft.com/internal/obd"/>
-  </ds:schemaRefs>
+  <ds:schemaRefs/>
 </ds:datastoreItem>
 </file>
 
-<file path=customXml/itemProps2.xml><?xml version="1.0" encoding="utf-8"?>
+<file path=customXml/itemProps4.xml><?xml version="1.0" encoding="utf-8"?>
 <ds:datastoreItem xmlns:ds="http://schemas.openxmlformats.org/officeDocument/2006/customXml" ds:itemID="{AED47698-1855-40F8-88F1-9046674C7C6F}">
-  <ds:schemaRefs>
-    <ds:schemaRef ds:uri="http://schemas.microsoft.com/office/2006/metadata/properties"/>
-    <ds:schemaRef ds:uri="http://schemas.microsoft.com/office/infopath/2007/PartnerControls"/>
-    <ds:schemaRef ds:uri="bd46642e-baf8-4e0b-90a8-08a61c43d436"/>
-    <ds:schemaRef ds:uri="da89c8aa-bdf1-4272-829d-0bf2fbc1fefc"/>
-  </ds:schemaRefs>
+  <ds:schemaRefs/>
 </ds:datastoreItem>
 </file>
 
-<file path=customXml/itemProps3.xml><?xml version="1.0" encoding="utf-8"?>
+<file path=customXml/itemProps5.xml><?xml version="1.0" encoding="utf-8"?>
 <ds:datastoreItem xmlns:ds="http://schemas.openxmlformats.org/officeDocument/2006/customXml" ds:itemID="{A168439B-1DAE-4F2B-934D-367C7A79D1E5}">
-  <ds:schemaRefs>
-    <ds:schemaRef ds:uri="http://schemas.microsoft.com/sharepoint/v3/contenttype/forms"/>
-  </ds:schemaRefs>
+  <ds:schemaRefs/>
 </ds:datastoreItem>
 </file>
</xml_diff>